<commit_message>
feat: Restructure PPTX to 5 slides and implement interactive HTML slide carousel on website
</commit_message>
<xml_diff>
--- a/docs/ai-evolution-from-chatbot-to-agent-builder.pptx
+++ b/docs/ai-evolution-from-chatbot-to-agent-builder.pptx
@@ -6,6 +6,10 @@
   </p:sldMasterIdLst>
   <p:sldIdLst>
     <p:sldId id="256" r:id="rId7"/>
+    <p:sldId id="257" r:id="rId8"/>
+    <p:sldId id="258" r:id="rId9"/>
+    <p:sldId id="259" r:id="rId10"/>
+    <p:sldId id="260" r:id="rId11"/>
   </p:sldIdLst>
   <p:sldSz cx="12191695" cy="6858000" type="screen4x3"/>
   <p:notesSz cx="6858000" cy="9144000"/>
@@ -3084,7 +3088,7 @@
     <p:bg>
       <p:bgPr>
         <a:solidFill>
-          <a:srgbClr val="1A1A2E"/>
+          <a:srgbClr val="0F0F1A"/>
         </a:solidFill>
         <a:effectLst/>
       </p:bgPr>
@@ -3104,8 +3108,8 @@
         </p:nvSpPr>
         <p:spPr>
           <a:xfrm>
-            <a:off x="457200" y="274320"/>
-            <a:ext cx="2743200" cy="365760"/>
+            <a:off x="914400" y="1097280"/>
+            <a:ext cx="10362895" cy="457200"/>
           </a:xfrm>
           <a:prstGeom prst="rect">
             <a:avLst/>
@@ -3119,7 +3123,7 @@
           <a:lstStyle/>
           <a:p>
             <a:pPr>
-              <a:defRPr sz="1400" b="1">
+              <a:defRPr sz="1600" b="1">
                 <a:solidFill>
                   <a:srgbClr val="FF6B6B"/>
                 </a:solidFill>
@@ -3127,7 +3131,7 @@
               </a:defRPr>
             </a:pPr>
             <a:r>
-              <a:t>[ AI ]</a:t>
+              <a:t>💡 [ AI ]</a:t>
             </a:r>
           </a:p>
         </p:txBody>
@@ -3140,8 +3144,8 @@
         </p:nvSpPr>
         <p:spPr>
           <a:xfrm>
-            <a:off x="457200" y="640080"/>
-            <a:ext cx="11277295" cy="914400"/>
+            <a:off x="914400" y="1645920"/>
+            <a:ext cx="10362895" cy="1828800"/>
           </a:xfrm>
           <a:prstGeom prst="rect">
             <a:avLst/>
@@ -3155,7 +3159,7 @@
           <a:lstStyle/>
           <a:p>
             <a:pPr>
-              <a:defRPr sz="3200" b="1">
+              <a:defRPr sz="3600" b="1">
                 <a:solidFill>
                   <a:srgbClr val="FFFFFF"/>
                 </a:solidFill>
@@ -3176,14 +3180,14 @@
         </p:nvSpPr>
         <p:spPr>
           <a:xfrm>
-            <a:off x="457200" y="1600200"/>
-            <a:ext cx="1828800" cy="36576"/>
+            <a:off x="914400" y="3474720"/>
+            <a:ext cx="2286000" cy="36576"/>
           </a:xfrm>
           <a:prstGeom prst="rect">
             <a:avLst/>
           </a:prstGeom>
           <a:solidFill>
-            <a:srgbClr val="64B5F6"/>
+            <a:srgbClr val="667EEA"/>
           </a:solidFill>
           <a:ln>
             <a:noFill/>
@@ -3219,8 +3223,8 @@
         </p:nvSpPr>
         <p:spPr>
           <a:xfrm>
-            <a:off x="457200" y="1828800"/>
-            <a:ext cx="11277295" cy="1097280"/>
+            <a:off x="914400" y="3840480"/>
+            <a:ext cx="10362895" cy="1828800"/>
           </a:xfrm>
           <a:prstGeom prst="rect">
             <a:avLst/>
@@ -3234,29 +3238,58 @@
           <a:lstStyle/>
           <a:p>
             <a:pPr>
-              <a:defRPr sz="1600">
+              <a:lnSpc>
+                <a:spcPct val="130000"/>
+              </a:lnSpc>
+              <a:defRPr sz="1800">
                 <a:solidFill>
-                  <a:srgbClr val="CCCCCC"/>
+                  <a:srgbClr val="A0A0B8"/>
                 </a:solidFill>
                 <a:latin typeface="Malgun Gothic"/>
               </a:defRPr>
             </a:pPr>
             <a:r>
-              <a:t>인공지능은 1956년 다트머스 회의에서 시작되어 두 번의 침체기를 겪었지만, 2017년 구글의 '어텐션 메커니즘'과 GPU의 발전으로 챗GPT와 같은 혁신을 이끌었습니다. 이제 AI는 단순한 챗봇을 넘어 목표 지향적이고 자율적으로 다단계 작업을 수행하는 '에이전트' 시대로 진화하고 있으며, 도메인 지식을 가진 누구나 AI를 활용해 문제를 해결하는 '빌더'가 될 수 있는 시대가 도래했습니다.</a:t>
-            </a:r>
-          </a:p>
-        </p:txBody>
-      </p:sp>
-      <p:sp>
-        <p:nvSpPr>
-          <p:cNvPr id="6" name="TextBox 5"/>
+              <a:t>챗GPT로 촉발된 인공지능 혁명의 흐름 속에서 2026년부터 본격화될 '에이전트 시대'의 특징과 멀티 에이전트 작동 방식, 그리고 AI 기술이 가져올 경제적 파급효과와 한국의 AI 경제 주권 확보 필요성을 설명합니다.</a:t>
+            </a:r>
+          </a:p>
+        </p:txBody>
+      </p:sp>
+    </p:spTree>
+  </p:cSld>
+  <p:clrMapOvr>
+    <a:masterClrMapping/>
+  </p:clrMapOvr>
+</p:sld>
+</file>
+
+<file path=ppt/slides/slide2.xml><?xml version="1.0" encoding="utf-8"?>
+<p:sld xmlns:a="http://schemas.openxmlformats.org/drawingml/2006/main" xmlns:p="http://schemas.openxmlformats.org/presentationml/2006/main" xmlns:r="http://schemas.openxmlformats.org/officeDocument/2006/relationships">
+  <p:cSld>
+    <p:bg>
+      <p:bgPr>
+        <a:solidFill>
+          <a:srgbClr val="0F0F1A"/>
+        </a:solidFill>
+        <a:effectLst/>
+      </p:bgPr>
+    </p:bg>
+    <p:spTree>
+      <p:nvGrpSpPr>
+        <p:cNvPr id="1" name=""/>
+        <p:cNvGrpSpPr/>
+        <p:nvPr/>
+      </p:nvGrpSpPr>
+      <p:grpSpPr/>
+      <p:sp>
+        <p:nvSpPr>
+          <p:cNvPr id="2" name="TextBox 1"/>
           <p:cNvSpPr txBox="1"/>
           <p:nvPr/>
         </p:nvSpPr>
         <p:spPr>
           <a:xfrm>
-            <a:off x="457200" y="3108960"/>
-            <a:ext cx="11277295" cy="2926080"/>
+            <a:off x="914400" y="548640"/>
+            <a:ext cx="10362895" cy="365760"/>
           </a:xfrm>
           <a:prstGeom prst="rect">
             <a:avLst/>
@@ -3264,102 +3297,35 @@
           <a:noFill/>
         </p:spPr>
         <p:txBody>
-          <a:bodyPr wrap="square">
+          <a:bodyPr wrap="none">
             <a:spAutoFit/>
           </a:bodyPr>
           <a:lstStyle/>
           <a:p>
             <a:pPr>
-              <a:spcAft>
-                <a:spcPts val="800"/>
-              </a:spcAft>
-              <a:defRPr sz="1300">
+              <a:defRPr sz="1200" b="1">
                 <a:solidFill>
-                  <a:srgbClr val="EEEEEE"/>
+                  <a:srgbClr val="667EEA"/>
                 </a:solidFill>
                 <a:latin typeface="Malgun Gothic"/>
               </a:defRPr>
             </a:pPr>
             <a:r>
-              <a:t>▸ AI의 역사와 챗GPT 혁명: AI는 1956년 다트머스 회의에서 개념화된 이후 두 번의 침체기를 겪었으나, 2017년 '어텐션 메커니즘'과 GPU의 병렬 처리 능력 덕분에 챗GPT와 같은 대화형 AI가 등장하며 대중화되었습니다.</a:t>
-            </a:r>
-          </a:p>
-          <a:p>
-            <a:pPr>
-              <a:spcAft>
-                <a:spcPts val="800"/>
-              </a:spcAft>
-              <a:defRPr sz="1300">
-                <a:solidFill>
-                  <a:srgbClr val="EEEEEE"/>
-                </a:solidFill>
-                <a:latin typeface="Malgun Gothic"/>
-              </a:defRPr>
-            </a:pPr>
-            <a:r>
-              <a:t>▸ 챗봇에서 에이전트 시대로의 전환: 챗GPT가 단일 질문에 답변하는 챗봇이었다면, 2026년부터는 목표를 부여하면 AI가 자율적으로 여러 단계를 거쳐 작업을 완성하는 '에이전트'가 핵심이 됩니다. 여러 에이전트가 협력하는 멀티 에이전트 구조는 AI의 신뢰도를 높이는 데 기여합니다.</a:t>
-            </a:r>
-          </a:p>
-          <a:p>
-            <a:pPr>
-              <a:spcAft>
-                <a:spcPts val="800"/>
-              </a:spcAft>
-              <a:defRPr sz="1300">
-                <a:solidFill>
-                  <a:srgbClr val="EEEEEE"/>
-                </a:solidFill>
-                <a:latin typeface="Malgun Gothic"/>
-              </a:defRPr>
-            </a:pPr>
-            <a:r>
-              <a:t>▸ AI 에이전트가 이끌 경제 변화: 2028년까지 기업 간(B2B) 거래의 90%가 AI 에이전트 간에 이루어지고, 2030년에는 '토큰'과 같은 프로그래머블 화폐가 전체 거래의 20%를 차지하며 GDP 측정 방식까지 변화시킬 수 있습니다.</a:t>
-            </a:r>
-          </a:p>
-          <a:p>
-            <a:pPr>
-              <a:spcAft>
-                <a:spcPts val="800"/>
-              </a:spcAft>
-              <a:defRPr sz="1300">
-                <a:solidFill>
-                  <a:srgbClr val="EEEEEE"/>
-                </a:solidFill>
-                <a:latin typeface="Malgun Gothic"/>
-              </a:defRPr>
-            </a:pPr>
-            <a:r>
-              <a:t>▸ AI 활용 트렌드의 진화: 하네스 엔지니어링: AI 활용 방식은 질문을 잘하는 '프롬프트 엔지니어링'에서 맥락을 제공하는 '컨텍스트 엔지니어링'을 거쳐, 이제는 여러 전문 에이전트의 작업을 효율적으로 조율하는 '하네스 엔지니어링'이 중요해지고 있습니다.</a:t>
-            </a:r>
-          </a:p>
-          <a:p>
-            <a:pPr>
-              <a:spcAft>
-                <a:spcPts val="800"/>
-              </a:spcAft>
-              <a:defRPr sz="1300">
-                <a:solidFill>
-                  <a:srgbClr val="EEEEEE"/>
-                </a:solidFill>
-                <a:latin typeface="Malgun Gothic"/>
-              </a:defRPr>
-            </a:pPr>
-            <a:r>
-              <a:t>▸ 도메인 지식 기반의 '빌더' 시대: AI 도구의 발전으로 개발자가 아니더라도 특정 분야의 전문 지식(도메인 날리지)을 가진 사람이라면 누구나 AI를 활용하여 복잡한 문제를 해결하고 혁신적인 시스템을 빠르게 구축할 수 있는 '빌더'가 될 수 있습니다.</a:t>
-            </a:r>
-          </a:p>
-        </p:txBody>
-      </p:sp>
-      <p:sp>
-        <p:nvSpPr>
-          <p:cNvPr id="7" name="TextBox 6"/>
+              <a:t>CORE INSIGHT 01 / 03</a:t>
+            </a:r>
+          </a:p>
+        </p:txBody>
+      </p:sp>
+      <p:sp>
+        <p:nvSpPr>
+          <p:cNvPr id="3" name="TextBox 2"/>
           <p:cNvSpPr txBox="1"/>
           <p:nvPr/>
         </p:nvSpPr>
         <p:spPr>
           <a:xfrm>
-            <a:off x="457200" y="6217920"/>
-            <a:ext cx="11277295" cy="457200"/>
+            <a:off x="914400" y="1097280"/>
+            <a:ext cx="10362895" cy="1097280"/>
           </a:xfrm>
           <a:prstGeom prst="rect">
             <a:avLst/>
@@ -3367,13 +3333,620 @@
           <a:noFill/>
         </p:spPr>
         <p:txBody>
+          <a:bodyPr wrap="square">
+            <a:spAutoFit/>
+          </a:bodyPr>
+          <a:lstStyle/>
+          <a:p>
+            <a:pPr>
+              <a:defRPr sz="3000" b="1">
+                <a:solidFill>
+                  <a:srgbClr val="FFFFFF"/>
+                </a:solidFill>
+                <a:latin typeface="Malgun Gothic"/>
+              </a:defRPr>
+            </a:pPr>
+            <a:r>
+              <a:t>자율적 에이전트 도래</a:t>
+            </a:r>
+          </a:p>
+        </p:txBody>
+      </p:sp>
+      <p:sp>
+        <p:nvSpPr>
+          <p:cNvPr id="4" name="Rectangle 3"/>
+          <p:cNvSpPr/>
+          <p:nvPr/>
+        </p:nvSpPr>
+        <p:spPr>
+          <a:xfrm>
+            <a:off x="914400" y="2286000"/>
+            <a:ext cx="10362895" cy="18288"/>
+          </a:xfrm>
+          <a:prstGeom prst="rect">
+            <a:avLst/>
+          </a:prstGeom>
+          <a:solidFill>
+            <a:srgbClr val="2D2D44"/>
+          </a:solidFill>
+          <a:ln>
+            <a:noFill/>
+          </a:ln>
+        </p:spPr>
+        <p:style>
+          <a:lnRef idx="1">
+            <a:schemeClr val="accent1"/>
+          </a:lnRef>
+          <a:fillRef idx="3">
+            <a:schemeClr val="accent1"/>
+          </a:fillRef>
+          <a:effectRef idx="2">
+            <a:schemeClr val="accent1"/>
+          </a:effectRef>
+          <a:fontRef idx="minor">
+            <a:schemeClr val="lt1"/>
+          </a:fontRef>
+        </p:style>
+        <p:txBody>
+          <a:bodyPr rtlCol="0" anchor="ctr"/>
+          <a:lstStyle/>
+          <a:p>
+            <a:pPr algn="ctr"/>
+          </a:p>
+        </p:txBody>
+      </p:sp>
+      <p:sp>
+        <p:nvSpPr>
+          <p:cNvPr id="5" name="TextBox 4"/>
+          <p:cNvSpPr txBox="1"/>
+          <p:nvPr/>
+        </p:nvSpPr>
+        <p:spPr>
+          <a:xfrm>
+            <a:off x="914400" y="2743200"/>
+            <a:ext cx="10362895" cy="3200400"/>
+          </a:xfrm>
+          <a:prstGeom prst="rect">
+            <a:avLst/>
+          </a:prstGeom>
+          <a:noFill/>
+        </p:spPr>
+        <p:txBody>
+          <a:bodyPr wrap="square">
+            <a:spAutoFit/>
+          </a:bodyPr>
+          <a:lstStyle/>
+          <a:p>
+            <a:pPr>
+              <a:lnSpc>
+                <a:spcPct val="140000"/>
+              </a:lnSpc>
+              <a:defRPr sz="2000">
+                <a:solidFill>
+                  <a:srgbClr val="E8E8F0"/>
+                </a:solidFill>
+                <a:latin typeface="Malgun Gothic"/>
+              </a:defRPr>
+            </a:pPr>
+            <a:r>
+              <a:t>단순한 질문-답변형 챗봇을 넘어, 스스로 판단하고 계획하여 복잡한 다단계 작업을 주도적으로 해결하는 멀티 에이전트 협업 생태계가 활성화됩니다.</a:t>
+            </a:r>
+          </a:p>
+        </p:txBody>
+      </p:sp>
+    </p:spTree>
+  </p:cSld>
+  <p:clrMapOvr>
+    <a:masterClrMapping/>
+  </p:clrMapOvr>
+</p:sld>
+</file>
+
+<file path=ppt/slides/slide3.xml><?xml version="1.0" encoding="utf-8"?>
+<p:sld xmlns:a="http://schemas.openxmlformats.org/drawingml/2006/main" xmlns:p="http://schemas.openxmlformats.org/presentationml/2006/main" xmlns:r="http://schemas.openxmlformats.org/officeDocument/2006/relationships">
+  <p:cSld>
+    <p:bg>
+      <p:bgPr>
+        <a:solidFill>
+          <a:srgbClr val="0F0F1A"/>
+        </a:solidFill>
+        <a:effectLst/>
+      </p:bgPr>
+    </p:bg>
+    <p:spTree>
+      <p:nvGrpSpPr>
+        <p:cNvPr id="1" name=""/>
+        <p:cNvGrpSpPr/>
+        <p:nvPr/>
+      </p:nvGrpSpPr>
+      <p:grpSpPr/>
+      <p:sp>
+        <p:nvSpPr>
+          <p:cNvPr id="2" name="TextBox 1"/>
+          <p:cNvSpPr txBox="1"/>
+          <p:nvPr/>
+        </p:nvSpPr>
+        <p:spPr>
+          <a:xfrm>
+            <a:off x="914400" y="548640"/>
+            <a:ext cx="10362895" cy="365760"/>
+          </a:xfrm>
+          <a:prstGeom prst="rect">
+            <a:avLst/>
+          </a:prstGeom>
+          <a:noFill/>
+        </p:spPr>
+        <p:txBody>
           <a:bodyPr wrap="none">
             <a:spAutoFit/>
           </a:bodyPr>
           <a:lstStyle/>
           <a:p>
             <a:pPr>
-              <a:defRPr sz="1000">
+              <a:defRPr sz="1200" b="1">
+                <a:solidFill>
+                  <a:srgbClr val="667EEA"/>
+                </a:solidFill>
+                <a:latin typeface="Malgun Gothic"/>
+              </a:defRPr>
+            </a:pPr>
+            <a:r>
+              <a:t>CORE INSIGHT 02 / 03</a:t>
+            </a:r>
+          </a:p>
+        </p:txBody>
+      </p:sp>
+      <p:sp>
+        <p:nvSpPr>
+          <p:cNvPr id="3" name="TextBox 2"/>
+          <p:cNvSpPr txBox="1"/>
+          <p:nvPr/>
+        </p:nvSpPr>
+        <p:spPr>
+          <a:xfrm>
+            <a:off x="914400" y="1097280"/>
+            <a:ext cx="10362895" cy="1097280"/>
+          </a:xfrm>
+          <a:prstGeom prst="rect">
+            <a:avLst/>
+          </a:prstGeom>
+          <a:noFill/>
+        </p:spPr>
+        <p:txBody>
+          <a:bodyPr wrap="square">
+            <a:spAutoFit/>
+          </a:bodyPr>
+          <a:lstStyle/>
+          <a:p>
+            <a:pPr>
+              <a:defRPr sz="3000" b="1">
+                <a:solidFill>
+                  <a:srgbClr val="FFFFFF"/>
+                </a:solidFill>
+                <a:latin typeface="Malgun Gothic"/>
+              </a:defRPr>
+            </a:pPr>
+            <a:r>
+              <a:t>엔지니어링 트렌드 변화</a:t>
+            </a:r>
+          </a:p>
+        </p:txBody>
+      </p:sp>
+      <p:sp>
+        <p:nvSpPr>
+          <p:cNvPr id="4" name="Rectangle 3"/>
+          <p:cNvSpPr/>
+          <p:nvPr/>
+        </p:nvSpPr>
+        <p:spPr>
+          <a:xfrm>
+            <a:off x="914400" y="2286000"/>
+            <a:ext cx="10362895" cy="18288"/>
+          </a:xfrm>
+          <a:prstGeom prst="rect">
+            <a:avLst/>
+          </a:prstGeom>
+          <a:solidFill>
+            <a:srgbClr val="2D2D44"/>
+          </a:solidFill>
+          <a:ln>
+            <a:noFill/>
+          </a:ln>
+        </p:spPr>
+        <p:style>
+          <a:lnRef idx="1">
+            <a:schemeClr val="accent1"/>
+          </a:lnRef>
+          <a:fillRef idx="3">
+            <a:schemeClr val="accent1"/>
+          </a:fillRef>
+          <a:effectRef idx="2">
+            <a:schemeClr val="accent1"/>
+          </a:effectRef>
+          <a:fontRef idx="minor">
+            <a:schemeClr val="lt1"/>
+          </a:fontRef>
+        </p:style>
+        <p:txBody>
+          <a:bodyPr rtlCol="0" anchor="ctr"/>
+          <a:lstStyle/>
+          <a:p>
+            <a:pPr algn="ctr"/>
+          </a:p>
+        </p:txBody>
+      </p:sp>
+      <p:sp>
+        <p:nvSpPr>
+          <p:cNvPr id="5" name="TextBox 4"/>
+          <p:cNvSpPr txBox="1"/>
+          <p:nvPr/>
+        </p:nvSpPr>
+        <p:spPr>
+          <a:xfrm>
+            <a:off x="914400" y="2743200"/>
+            <a:ext cx="10362895" cy="3200400"/>
+          </a:xfrm>
+          <a:prstGeom prst="rect">
+            <a:avLst/>
+          </a:prstGeom>
+          <a:noFill/>
+        </p:spPr>
+        <p:txBody>
+          <a:bodyPr wrap="square">
+            <a:spAutoFit/>
+          </a:bodyPr>
+          <a:lstStyle/>
+          <a:p>
+            <a:pPr>
+              <a:lnSpc>
+                <a:spcPct val="140000"/>
+              </a:lnSpc>
+              <a:defRPr sz="2000">
+                <a:solidFill>
+                  <a:srgbClr val="E8E8F0"/>
+                </a:solidFill>
+                <a:latin typeface="Malgun Gothic"/>
+              </a:defRPr>
+            </a:pPr>
+            <a:r>
+              <a:t>적절한 질문을 던지는 프롬프트 엔지니어링을 넘어, 다수의 AI 에이전트들을 적절하게 조율하고 통제하는 하네스(Harness) 엔지니어링이 미래 직무의 핵심으로 부상합니다.</a:t>
+            </a:r>
+          </a:p>
+        </p:txBody>
+      </p:sp>
+    </p:spTree>
+  </p:cSld>
+  <p:clrMapOvr>
+    <a:masterClrMapping/>
+  </p:clrMapOvr>
+</p:sld>
+</file>
+
+<file path=ppt/slides/slide4.xml><?xml version="1.0" encoding="utf-8"?>
+<p:sld xmlns:a="http://schemas.openxmlformats.org/drawingml/2006/main" xmlns:p="http://schemas.openxmlformats.org/presentationml/2006/main" xmlns:r="http://schemas.openxmlformats.org/officeDocument/2006/relationships">
+  <p:cSld>
+    <p:bg>
+      <p:bgPr>
+        <a:solidFill>
+          <a:srgbClr val="0F0F1A"/>
+        </a:solidFill>
+        <a:effectLst/>
+      </p:bgPr>
+    </p:bg>
+    <p:spTree>
+      <p:nvGrpSpPr>
+        <p:cNvPr id="1" name=""/>
+        <p:cNvGrpSpPr/>
+        <p:nvPr/>
+      </p:nvGrpSpPr>
+      <p:grpSpPr/>
+      <p:sp>
+        <p:nvSpPr>
+          <p:cNvPr id="2" name="TextBox 1"/>
+          <p:cNvSpPr txBox="1"/>
+          <p:nvPr/>
+        </p:nvSpPr>
+        <p:spPr>
+          <a:xfrm>
+            <a:off x="914400" y="548640"/>
+            <a:ext cx="10362895" cy="365760"/>
+          </a:xfrm>
+          <a:prstGeom prst="rect">
+            <a:avLst/>
+          </a:prstGeom>
+          <a:noFill/>
+        </p:spPr>
+        <p:txBody>
+          <a:bodyPr wrap="none">
+            <a:spAutoFit/>
+          </a:bodyPr>
+          <a:lstStyle/>
+          <a:p>
+            <a:pPr>
+              <a:defRPr sz="1200" b="1">
+                <a:solidFill>
+                  <a:srgbClr val="667EEA"/>
+                </a:solidFill>
+                <a:latin typeface="Malgun Gothic"/>
+              </a:defRPr>
+            </a:pPr>
+            <a:r>
+              <a:t>CORE INSIGHT 03 / 03</a:t>
+            </a:r>
+          </a:p>
+        </p:txBody>
+      </p:sp>
+      <p:sp>
+        <p:nvSpPr>
+          <p:cNvPr id="3" name="TextBox 2"/>
+          <p:cNvSpPr txBox="1"/>
+          <p:nvPr/>
+        </p:nvSpPr>
+        <p:spPr>
+          <a:xfrm>
+            <a:off x="914400" y="1097280"/>
+            <a:ext cx="10362895" cy="1097280"/>
+          </a:xfrm>
+          <a:prstGeom prst="rect">
+            <a:avLst/>
+          </a:prstGeom>
+          <a:noFill/>
+        </p:spPr>
+        <p:txBody>
+          <a:bodyPr wrap="square">
+            <a:spAutoFit/>
+          </a:bodyPr>
+          <a:lstStyle/>
+          <a:p>
+            <a:pPr>
+              <a:defRPr sz="3000" b="1">
+                <a:solidFill>
+                  <a:srgbClr val="FFFFFF"/>
+                </a:solidFill>
+                <a:latin typeface="Malgun Gothic"/>
+              </a:defRPr>
+            </a:pPr>
+            <a:r>
+              <a:t>AI 경제 주권과 국산 생태계</a:t>
+            </a:r>
+          </a:p>
+        </p:txBody>
+      </p:sp>
+      <p:sp>
+        <p:nvSpPr>
+          <p:cNvPr id="4" name="Rectangle 3"/>
+          <p:cNvSpPr/>
+          <p:nvPr/>
+        </p:nvSpPr>
+        <p:spPr>
+          <a:xfrm>
+            <a:off x="914400" y="2286000"/>
+            <a:ext cx="10362895" cy="18288"/>
+          </a:xfrm>
+          <a:prstGeom prst="rect">
+            <a:avLst/>
+          </a:prstGeom>
+          <a:solidFill>
+            <a:srgbClr val="2D2D44"/>
+          </a:solidFill>
+          <a:ln>
+            <a:noFill/>
+          </a:ln>
+        </p:spPr>
+        <p:style>
+          <a:lnRef idx="1">
+            <a:schemeClr val="accent1"/>
+          </a:lnRef>
+          <a:fillRef idx="3">
+            <a:schemeClr val="accent1"/>
+          </a:fillRef>
+          <a:effectRef idx="2">
+            <a:schemeClr val="accent1"/>
+          </a:effectRef>
+          <a:fontRef idx="minor">
+            <a:schemeClr val="lt1"/>
+          </a:fontRef>
+        </p:style>
+        <p:txBody>
+          <a:bodyPr rtlCol="0" anchor="ctr"/>
+          <a:lstStyle/>
+          <a:p>
+            <a:pPr algn="ctr"/>
+          </a:p>
+        </p:txBody>
+      </p:sp>
+      <p:sp>
+        <p:nvSpPr>
+          <p:cNvPr id="5" name="TextBox 4"/>
+          <p:cNvSpPr txBox="1"/>
+          <p:nvPr/>
+        </p:nvSpPr>
+        <p:spPr>
+          <a:xfrm>
+            <a:off x="914400" y="2743200"/>
+            <a:ext cx="10362895" cy="3200400"/>
+          </a:xfrm>
+          <a:prstGeom prst="rect">
+            <a:avLst/>
+          </a:prstGeom>
+          <a:noFill/>
+        </p:spPr>
+        <p:txBody>
+          <a:bodyPr wrap="square">
+            <a:spAutoFit/>
+          </a:bodyPr>
+          <a:lstStyle/>
+          <a:p>
+            <a:pPr>
+              <a:lnSpc>
+                <a:spcPct val="140000"/>
+              </a:lnSpc>
+              <a:defRPr sz="2000">
+                <a:solidFill>
+                  <a:srgbClr val="E8E8F0"/>
+                </a:solidFill>
+                <a:latin typeface="Malgun Gothic"/>
+              </a:defRPr>
+            </a:pPr>
+            <a:r>
+              <a:t>폭증할 AI 토큰 사용량으로 인한 경상수지 적자를 방지하고, 글로벌 빅테크 독점에 대응하기 위해 한국 자체의 AI 오케스트레이션 모델과 주권 확보가 필수적입니다.</a:t>
+            </a:r>
+          </a:p>
+        </p:txBody>
+      </p:sp>
+    </p:spTree>
+  </p:cSld>
+  <p:clrMapOvr>
+    <a:masterClrMapping/>
+  </p:clrMapOvr>
+</p:sld>
+</file>
+
+<file path=ppt/slides/slide5.xml><?xml version="1.0" encoding="utf-8"?>
+<p:sld xmlns:a="http://schemas.openxmlformats.org/drawingml/2006/main" xmlns:p="http://schemas.openxmlformats.org/presentationml/2006/main" xmlns:r="http://schemas.openxmlformats.org/officeDocument/2006/relationships">
+  <p:cSld>
+    <p:bg>
+      <p:bgPr>
+        <a:solidFill>
+          <a:srgbClr val="0F0F1A"/>
+        </a:solidFill>
+        <a:effectLst/>
+      </p:bgPr>
+    </p:bg>
+    <p:spTree>
+      <p:nvGrpSpPr>
+        <p:cNvPr id="1" name=""/>
+        <p:cNvGrpSpPr/>
+        <p:nvPr/>
+      </p:nvGrpSpPr>
+      <p:grpSpPr/>
+      <p:sp>
+        <p:nvSpPr>
+          <p:cNvPr id="2" name="Rounded Rectangle 1"/>
+          <p:cNvSpPr/>
+          <p:nvPr/>
+        </p:nvSpPr>
+        <p:spPr>
+          <a:xfrm>
+            <a:off x="914400" y="1371600"/>
+            <a:ext cx="10362895" cy="3474720"/>
+          </a:xfrm>
+          <a:prstGeom prst="roundRect">
+            <a:avLst/>
+          </a:prstGeom>
+          <a:solidFill>
+            <a:srgbClr val="1A1A2E"/>
+          </a:solidFill>
+          <a:ln>
+            <a:solidFill>
+              <a:srgbClr val="2D2D44"/>
+            </a:solidFill>
+          </a:ln>
+        </p:spPr>
+        <p:style>
+          <a:lnRef idx="1">
+            <a:schemeClr val="accent1"/>
+          </a:lnRef>
+          <a:fillRef idx="3">
+            <a:schemeClr val="accent1"/>
+          </a:fillRef>
+          <a:effectRef idx="2">
+            <a:schemeClr val="accent1"/>
+          </a:effectRef>
+          <a:fontRef idx="minor">
+            <a:schemeClr val="lt1"/>
+          </a:fontRef>
+        </p:style>
+        <p:txBody>
+          <a:bodyPr rtlCol="0" anchor="ctr"/>
+          <a:lstStyle/>
+          <a:p>
+            <a:pPr algn="ctr"/>
+          </a:p>
+        </p:txBody>
+      </p:sp>
+      <p:sp>
+        <p:nvSpPr>
+          <p:cNvPr id="3" name="TextBox 2"/>
+          <p:cNvSpPr txBox="1"/>
+          <p:nvPr/>
+        </p:nvSpPr>
+        <p:spPr>
+          <a:xfrm>
+            <a:off x="1371600" y="1645920"/>
+            <a:ext cx="9448495" cy="2926080"/>
+          </a:xfrm>
+          <a:prstGeom prst="rect">
+            <a:avLst/>
+          </a:prstGeom>
+          <a:noFill/>
+        </p:spPr>
+        <p:txBody>
+          <a:bodyPr wrap="square">
+            <a:spAutoFit/>
+          </a:bodyPr>
+          <a:lstStyle/>
+          <a:p>
+            <a:pPr>
+              <a:spcAft>
+                <a:spcPts val="1400"/>
+              </a:spcAft>
+              <a:defRPr sz="1400" b="1">
+                <a:solidFill>
+                  <a:srgbClr val="FF6B6B"/>
+                </a:solidFill>
+                <a:latin typeface="Malgun Gothic"/>
+              </a:defRPr>
+            </a:pPr>
+            <a:r>
+              <a:t>🎯 AI 추천사 및 시청 가치</a:t>
+            </a:r>
+          </a:p>
+          <a:p>
+            <a:pPr>
+              <a:lnSpc>
+                <a:spcPct val="130000"/>
+              </a:lnSpc>
+              <a:defRPr sz="1800" i="1">
+                <a:solidFill>
+                  <a:srgbClr val="E8E8F0"/>
+                </a:solidFill>
+                <a:latin typeface="Malgun Gothic"/>
+              </a:defRPr>
+            </a:pPr>
+            <a:r>
+              <a:t>눈앞에 도래한 에이전트 협업 시대의 본질과 미래 일자리의 변화를 일반인 눈높이에서 가장 직관적으로 통찰하게 돕는 영상입니다. 인공지능의 거대한 흐름 속에서 기회를 포착하고자 하는 모든 분들께 추천합니다.</a:t>
+            </a:r>
+          </a:p>
+        </p:txBody>
+      </p:sp>
+      <p:sp>
+        <p:nvSpPr>
+          <p:cNvPr id="4" name="TextBox 3"/>
+          <p:cNvSpPr txBox="1"/>
+          <p:nvPr/>
+        </p:nvSpPr>
+        <p:spPr>
+          <a:xfrm>
+            <a:off x="914400" y="5303520"/>
+            <a:ext cx="10362895" cy="914400"/>
+          </a:xfrm>
+          <a:prstGeom prst="rect">
+            <a:avLst/>
+          </a:prstGeom>
+          <a:noFill/>
+        </p:spPr>
+        <p:txBody>
+          <a:bodyPr wrap="square">
+            <a:spAutoFit/>
+          </a:bodyPr>
+          <a:lstStyle/>
+          <a:p>
+            <a:pPr>
+              <a:lnSpc>
+                <a:spcPct val="130000"/>
+              </a:lnSpc>
+              <a:defRPr sz="1200">
                 <a:solidFill>
                   <a:srgbClr val="888888"/>
                 </a:solidFill>
@@ -3381,7 +3954,11 @@
               </a:defRPr>
             </a:pPr>
             <a:r>
-              <a:t>Keywords: 인공지능, AI 에이전트, 챗GPT, AI 트렌드, 빌더 시대  |  🔗 https://youtu.be/ChsmNLwoHmw</a:t>
+              <a:t>🏷️ Keywords: AI, 에이전트, 챗GPT, GPU, 어텐션 메커니즘, 하네스 엔지니어링, 빌더, 토큰 이코노미, 경제 주권</a:t>
+            </a:r>
+            <a:br/>
+            <a:r>
+              <a:t>🔗 Source: https://youtu.be/ChsmNLwoHmw</a:t>
             </a:r>
           </a:p>
         </p:txBody>

</xml_diff>